<commit_message>
Schema + docs: chl/orp/oil/algae columns dropped from Supabase
Columns were dropped in production (2026-10-08). The live readings_daily view
still referenced chl, so it was dropped and recreated from schema.sql.
schema.sql no longer creates the 4 columns; docs/ER/slides no longer call
them reserve columns.

Co-Authored-By: Claude Opus 5.5 <noreply@anthropic.com>
</commit_message>
<xml_diff>
--- a/buoy-thesis-slides.pptx
+++ b/buoy-thesis-slides.pptx
@@ -6818,7 +6818,7 @@
                 <a:ea typeface="Tahoma" pitchFamily="34" charset="-122"/>
                 <a:cs typeface="Tahoma" pitchFamily="34" charset="-120"/>
               </a:rPr>
-              <a:t>ติดตั้งหัววัดเสริม ORP / คลอโรฟิลล์ / น้ำมัน / สาหร่าย (ระบบรองรับไว้แล้ว)</a:t>
+              <a:t>ติดตั้งหัววัดเสริม ORP / คลอโรฟิลล์ / น้ำมัน / สาหร่าย เพื่อเฝ้าระวังสาหร่ายบลูมและน้ำมัน</a:t>
             </a:r>
             <a:endParaRPr lang="en-US" sz="1300" dirty="0"/>
           </a:p>
@@ -11799,7 +11799,7 @@
                 <a:ea typeface="Tahoma" pitchFamily="34" charset="-122"/>
                 <a:cs typeface="Tahoma" pitchFamily="34" charset="-120"/>
               </a:rPr>
-              <a:t>— เซนเซอร์รองรับหัววัดเสริม แต่ชุดที่ใช้ไม่ได้ติดตั้ง ข้อมูลจริงอ่านได้ 0 ทุกแถว (ORP ในน้ำทะเลจริงต้องได้หลักร้อย mV) จึงตัดออก และเก็บคอลัมน์ฐานข้อมูลไว้รองรับการติดเพิ่ม
+              <a:t>— เซนเซอร์รองรับหัววัดเสริม แต่ชุดที่ใช้ไม่ได้ติดตั้ง ข้อมูลจริงอ่านได้ 0 ทุกแถว (ORP ในน้ำทะเลจริงต้องได้หลักร้อย mV) จึงตัดออกทั้ง firmware ซอฟต์แวร์ และฐานข้อมูล
 </a:t>
             </a:r>
             <a:pPr indent="0" marL="0">

</xml_diff>